<commit_message>
fix: align PPT with 72시간 골든타임 messaging + correct scoring 25/25/20/20/10
Co-Authored-By: Claude Opus 4.6 (1M context) <noreply@anthropic.com>
</commit_message>
<xml_diff>
--- a/submission/DistrictPilot_AI_Hackathon_Final.pptx
+++ b/submission/DistrictPilot_AI_Hackathon_Final.pptx
@@ -3171,7 +3171,7 @@
               </a:defRPr>
             </a:pPr>
             <a:r>
-              <a:t>서초/영등포/중구 전입·이사 수요 오케스트레이션 에이전트</a:t>
+              <a:t>서초/영등포/중구 이사 직후 72시간 골든타임 — 홈서비스 수요 예측 AI 에이전트</a:t>
             </a:r>
           </a:p>
         </p:txBody>
@@ -3450,7 +3450,7 @@
               </a:defRPr>
             </a:pPr>
             <a:r>
-              <a:t>DistrictPilot AI — 전입·이사 신호를 홈서비스 액션으로</a:t>
+              <a:t>이사 직후 72시간 골든타임을 예측하고 홈서비스 집행 액션을 추천합니다</a:t>
             </a:r>
           </a:p>
         </p:txBody>
@@ -3784,7 +3784,7 @@
               </a:defRPr>
             </a:pPr>
             <a:r>
-              <a:t>🏢 민간 사업자</a:t>
+              <a:t>이사 직후 72시간 — 홈서비스 골든타임 캡처</a:t>
             </a:r>
           </a:p>
         </p:txBody>
@@ -3870,7 +3870,7 @@
               </a:defRPr>
             </a:pPr>
             <a:r>
-              <a:t>🏛️ 자치구 행정</a:t>
+              <a:t>확장: 자치구 행정 서비스 (Next Phase)</a:t>
             </a:r>
           </a:p>
         </p:txBody>
@@ -3905,23 +3905,23 @@
               </a:defRPr>
             </a:pPr>
             <a:r>
-              <a:t>• 전입신고 창구 2→4개 확대</a:t>
+              <a:t>같은 예측 엔진 기반 확장 가능</a:t>
             </a:r>
             <a:br/>
             <a:r>
-              <a:t>• 청년(20-39) 전입 → 주거 지원금 안내</a:t>
+              <a:t/>
             </a:r>
             <a:br/>
             <a:r>
-              <a:t>• 가족 전입 → 보육시설 사전 준비</a:t>
+              <a:t/>
             </a:r>
             <a:br/>
             <a:r>
-              <a:t>• 고령 전입 → 노인 돌봄 인력 배치</a:t>
+              <a:t/>
             </a:r>
             <a:br/>
             <a:r>
-              <a:t>• 상권 불안정 → 소상공인 지원금 우선 배정</a:t>
+              <a:t/>
             </a:r>
           </a:p>
         </p:txBody>
@@ -3956,7 +3956,7 @@
               </a:defRPr>
             </a:pPr>
             <a:r>
-              <a:t>→ 비용은 동일, 임팩트는 2배. 하나의 Snowflake 계정에서 민간·공공 동시 서빙.</a:t>
+              <a:t>확장: 자치구 행정 서비스 (Next Phase)</a:t>
             </a:r>
           </a:p>
         </p:txBody>
@@ -5232,7 +5232,7 @@
               </a:defRPr>
             </a:pPr>
             <a:r>
-              <a:t>문제 정의 및 접근법 (20점)</a:t>
+              <a:t>비즈니스 임팩트 (25점)</a:t>
             </a:r>
           </a:p>
         </p:txBody>
@@ -5302,7 +5302,7 @@
               </a:defRPr>
             </a:pPr>
             <a:r>
-              <a:t>기술 구현 (30점)</a:t>
+              <a:t>기술 구현 (25점)</a:t>
             </a:r>
           </a:p>
         </p:txBody>
@@ -5372,7 +5372,7 @@
               </a:defRPr>
             </a:pPr>
             <a:r>
-              <a:t>결과 품질 및 인사이트 (30점)</a:t>
+              <a:t>솔루션 완성도 (20점)</a:t>
             </a:r>
           </a:p>
         </p:txBody>
@@ -5442,7 +5442,7 @@
               </a:defRPr>
             </a:pPr>
             <a:r>
-              <a:t>발표 품질 (20점)</a:t>
+              <a:t>데이터 분석 및 인사이트 (20점) + 발표 품질 (10점)</a:t>
             </a:r>
           </a:p>
         </p:txBody>
@@ -5477,7 +5477,7 @@
               </a:defRPr>
             </a:pPr>
             <a:r>
-              <a:t>5탭 라이브 데모, Judge Fast Path, Q&amp;A 7문항</a:t>
+              <a:t>5탭 라이브 데모, Judge Fast Path, Q&amp;A 9문항</a:t>
             </a:r>
           </a:p>
         </p:txBody>

</xml_diff>